<commit_message>
adapt format to be used by digi and the rest and adapt role prompts
</commit_message>
<xml_diff>
--- a/backend/data/input/SC&O TEMPLATE.pptx
+++ b/backend/data/input/SC&O TEMPLATE.pptx
@@ -197,7 +197,7 @@
           <a:p>
             <a:fld id="{39FACA13-D921-4963-933E-D3FA6435469F}" type="datetimeFigureOut">
               <a:rPr lang="es-AR" smtClean="0"/>
-              <a:t>26/12/2025</a:t>
+              <a:t>7/1/2026</a:t>
             </a:fld>
             <a:endParaRPr lang="es-AR"/>
           </a:p>
@@ -1312,7 +1312,7 @@
             <a:fld id="{EDCDE1A5-7B8C-446C-B047-DEF343C830D4}" type="datetime2">
               <a:rPr lang="es-MX" smtClean="0"/>
               <a:pPr/>
-              <a:t>viernes, 26 de diciembre de 2025</a:t>
+              <a:t>miércoles, 7 de enero de 2026</a:t>
             </a:fld>
             <a:endParaRPr lang="es-MX"/>
           </a:p>
@@ -2906,180 +2906,11 @@
           </a:lstStyle>
           <a:p>
             <a:r>
-              <a:rPr lang="en-US" sz="3200" dirty="0"/>
+              <a:rPr lang="en-US" sz="3200" b="0" dirty="0">
+                <a:latin typeface="Graphik Semibold" panose="020B0703030202060203" pitchFamily="34" charset="0"/>
+              </a:rPr>
               <a:t>NAME SURNAME</a:t>
             </a:r>
-          </a:p>
-        </p:txBody>
-      </p:sp>
-      <p:sp>
-        <p:nvSpPr>
-          <p:cNvPr id="17" name="Role_4">
-            <a:extLst>
-              <a:ext uri="{FF2B5EF4-FFF2-40B4-BE49-F238E27FC236}">
-                <a16:creationId xmlns:a16="http://schemas.microsoft.com/office/drawing/2014/main" id="{3604742C-8AC1-B97D-26EE-73CEC6F6F2E6}"/>
-              </a:ext>
-            </a:extLst>
-          </p:cNvPr>
-          <p:cNvSpPr/>
-          <p:nvPr/>
-        </p:nvSpPr>
-        <p:spPr bwMode="auto">
-          <a:xfrm>
-            <a:off x="3587766" y="5415850"/>
-            <a:ext cx="8155581" cy="1152003"/>
-          </a:xfrm>
-          <a:prstGeom prst="rect">
-            <a:avLst/>
-          </a:prstGeom>
-          <a:ln>
-            <a:noFill/>
-          </a:ln>
-        </p:spPr>
-        <p:style>
-          <a:lnRef idx="2">
-            <a:schemeClr val="accent1"/>
-          </a:lnRef>
-          <a:fillRef idx="1">
-            <a:schemeClr val="lt1"/>
-          </a:fillRef>
-          <a:effectRef idx="0">
-            <a:schemeClr val="accent1"/>
-          </a:effectRef>
-          <a:fontRef idx="minor">
-            <a:schemeClr val="dk1"/>
-          </a:fontRef>
-        </p:style>
-        <p:txBody>
-          <a:bodyPr lIns="91440" tIns="91440" rIns="91440" bIns="91440" rtlCol="0" anchor="t">
-            <a:noAutofit/>
-          </a:bodyPr>
-          <a:lstStyle/>
-          <a:p>
-            <a:pPr fontAlgn="base">
-              <a:defRPr/>
-            </a:pPr>
-            <a:endParaRPr lang="es-AR" sz="900" dirty="0">
-              <a:solidFill>
-                <a:srgbClr val="666666"/>
-              </a:solidFill>
-              <a:latin typeface="Graphik" panose="020B0503030202060203" pitchFamily="34" charset="0"/>
-              <a:cs typeface="Calibri" panose="020F0502020204030204" pitchFamily="34" charset="0"/>
-            </a:endParaRPr>
-          </a:p>
-        </p:txBody>
-      </p:sp>
-      <p:sp>
-        <p:nvSpPr>
-          <p:cNvPr id="19" name="Role_3">
-            <a:extLst>
-              <a:ext uri="{FF2B5EF4-FFF2-40B4-BE49-F238E27FC236}">
-                <a16:creationId xmlns:a16="http://schemas.microsoft.com/office/drawing/2014/main" id="{40506730-669B-A08A-08F4-CCF7C0F9CFFB}"/>
-              </a:ext>
-            </a:extLst>
-          </p:cNvPr>
-          <p:cNvSpPr/>
-          <p:nvPr/>
-        </p:nvSpPr>
-        <p:spPr bwMode="auto">
-          <a:xfrm>
-            <a:off x="3587765" y="4197874"/>
-            <a:ext cx="8155581" cy="1152003"/>
-          </a:xfrm>
-          <a:prstGeom prst="rect">
-            <a:avLst/>
-          </a:prstGeom>
-          <a:ln>
-            <a:noFill/>
-          </a:ln>
-        </p:spPr>
-        <p:style>
-          <a:lnRef idx="2">
-            <a:schemeClr val="accent2"/>
-          </a:lnRef>
-          <a:fillRef idx="1">
-            <a:schemeClr val="lt1"/>
-          </a:fillRef>
-          <a:effectRef idx="0">
-            <a:schemeClr val="accent2"/>
-          </a:effectRef>
-          <a:fontRef idx="minor">
-            <a:schemeClr val="dk1"/>
-          </a:fontRef>
-        </p:style>
-        <p:txBody>
-          <a:bodyPr lIns="91440" tIns="91440" rIns="91440" bIns="91440" rtlCol="0" anchor="t">
-            <a:noAutofit/>
-          </a:bodyPr>
-          <a:lstStyle/>
-          <a:p>
-            <a:pPr fontAlgn="base">
-              <a:defRPr/>
-            </a:pPr>
-            <a:endParaRPr lang="es-AR" sz="1000" dirty="0">
-              <a:solidFill>
-                <a:srgbClr val="666666"/>
-              </a:solidFill>
-              <a:latin typeface="Graphik" panose="020B0503030202060203" pitchFamily="34" charset="0"/>
-              <a:cs typeface="Calibri" panose="020F0502020204030204" pitchFamily="34" charset="0"/>
-            </a:endParaRPr>
-          </a:p>
-        </p:txBody>
-      </p:sp>
-      <p:sp>
-        <p:nvSpPr>
-          <p:cNvPr id="20" name="Role_2">
-            <a:extLst>
-              <a:ext uri="{FF2B5EF4-FFF2-40B4-BE49-F238E27FC236}">
-                <a16:creationId xmlns:a16="http://schemas.microsoft.com/office/drawing/2014/main" id="{7F67FAF4-8E85-4C92-A6A8-799BB4F907BE}"/>
-              </a:ext>
-            </a:extLst>
-          </p:cNvPr>
-          <p:cNvSpPr/>
-          <p:nvPr/>
-        </p:nvSpPr>
-        <p:spPr bwMode="auto">
-          <a:xfrm>
-            <a:off x="3587765" y="2979899"/>
-            <a:ext cx="8155581" cy="1152003"/>
-          </a:xfrm>
-          <a:prstGeom prst="rect">
-            <a:avLst/>
-          </a:prstGeom>
-          <a:ln>
-            <a:noFill/>
-          </a:ln>
-        </p:spPr>
-        <p:style>
-          <a:lnRef idx="2">
-            <a:schemeClr val="accent2"/>
-          </a:lnRef>
-          <a:fillRef idx="1">
-            <a:schemeClr val="lt1"/>
-          </a:fillRef>
-          <a:effectRef idx="0">
-            <a:schemeClr val="accent2"/>
-          </a:effectRef>
-          <a:fontRef idx="minor">
-            <a:schemeClr val="dk1"/>
-          </a:fontRef>
-        </p:style>
-        <p:txBody>
-          <a:bodyPr lIns="91440" tIns="91440" rIns="91440" bIns="91440" rtlCol="0" anchor="t">
-            <a:noAutofit/>
-          </a:bodyPr>
-          <a:lstStyle/>
-          <a:p>
-            <a:pPr fontAlgn="base">
-              <a:defRPr/>
-            </a:pPr>
-            <a:endParaRPr lang="es-AR" sz="900" dirty="0">
-              <a:solidFill>
-                <a:srgbClr val="666666"/>
-              </a:solidFill>
-              <a:latin typeface="Graphik" panose="020B0503030202060203" pitchFamily="34" charset="0"/>
-              <a:cs typeface="Calibri" panose="020F0502020204030204" pitchFamily="34" charset="0"/>
-            </a:endParaRPr>
           </a:p>
         </p:txBody>
       </p:sp>
@@ -3099,8 +2930,421 @@
         </p:nvSpPr>
         <p:spPr bwMode="auto">
           <a:xfrm>
-            <a:off x="3587765" y="1768882"/>
-            <a:ext cx="8155581" cy="1152003"/>
+            <a:off x="3587765" y="1656911"/>
+            <a:ext cx="8155581" cy="576002"/>
+          </a:xfrm>
+          <a:prstGeom prst="rect">
+            <a:avLst/>
+          </a:prstGeom>
+          <a:ln>
+            <a:noFill/>
+          </a:ln>
+        </p:spPr>
+        <p:style>
+          <a:lnRef idx="2">
+            <a:schemeClr val="accent1"/>
+          </a:lnRef>
+          <a:fillRef idx="1">
+            <a:schemeClr val="lt1"/>
+          </a:fillRef>
+          <a:effectRef idx="0">
+            <a:schemeClr val="accent1"/>
+          </a:effectRef>
+          <a:fontRef idx="minor">
+            <a:schemeClr val="dk1"/>
+          </a:fontRef>
+        </p:style>
+        <p:txBody>
+          <a:bodyPr lIns="91440" tIns="91440" rIns="91440" bIns="91440" rtlCol="0" anchor="t">
+            <a:noAutofit/>
+          </a:bodyPr>
+          <a:lstStyle/>
+          <a:p>
+            <a:pPr fontAlgn="base">
+              <a:defRPr/>
+            </a:pPr>
+            <a:endParaRPr lang="es-AR" sz="900" dirty="0">
+              <a:solidFill>
+                <a:srgbClr val="666666"/>
+              </a:solidFill>
+              <a:latin typeface="Graphik" panose="020B0503030202060203" pitchFamily="34" charset="0"/>
+              <a:cs typeface="Calibri" panose="020F0502020204030204" pitchFamily="34" charset="0"/>
+            </a:endParaRPr>
+          </a:p>
+        </p:txBody>
+      </p:sp>
+      <p:sp>
+        <p:nvSpPr>
+          <p:cNvPr id="8" name="Role_2">
+            <a:extLst>
+              <a:ext uri="{FF2B5EF4-FFF2-40B4-BE49-F238E27FC236}">
+                <a16:creationId xmlns:a16="http://schemas.microsoft.com/office/drawing/2014/main" id="{F1C2E025-CDB6-C1F9-EA83-B5DE94D13A02}"/>
+              </a:ext>
+            </a:extLst>
+          </p:cNvPr>
+          <p:cNvSpPr>
+            <a:spLocks noChangeAspect="1"/>
+          </p:cNvSpPr>
+          <p:nvPr/>
+        </p:nvSpPr>
+        <p:spPr bwMode="auto">
+          <a:xfrm>
+            <a:off x="3587764" y="2288090"/>
+            <a:ext cx="8155581" cy="576002"/>
+          </a:xfrm>
+          <a:prstGeom prst="rect">
+            <a:avLst/>
+          </a:prstGeom>
+          <a:ln>
+            <a:noFill/>
+          </a:ln>
+        </p:spPr>
+        <p:style>
+          <a:lnRef idx="2">
+            <a:schemeClr val="accent1"/>
+          </a:lnRef>
+          <a:fillRef idx="1">
+            <a:schemeClr val="lt1"/>
+          </a:fillRef>
+          <a:effectRef idx="0">
+            <a:schemeClr val="accent1"/>
+          </a:effectRef>
+          <a:fontRef idx="minor">
+            <a:schemeClr val="dk1"/>
+          </a:fontRef>
+        </p:style>
+        <p:txBody>
+          <a:bodyPr lIns="91440" tIns="91440" rIns="91440" bIns="91440" rtlCol="0" anchor="t">
+            <a:noAutofit/>
+          </a:bodyPr>
+          <a:lstStyle/>
+          <a:p>
+            <a:pPr fontAlgn="base">
+              <a:defRPr/>
+            </a:pPr>
+            <a:endParaRPr lang="es-AR" sz="900" dirty="0">
+              <a:solidFill>
+                <a:srgbClr val="666666"/>
+              </a:solidFill>
+              <a:latin typeface="Graphik" panose="020B0503030202060203" pitchFamily="34" charset="0"/>
+              <a:cs typeface="Calibri" panose="020F0502020204030204" pitchFamily="34" charset="0"/>
+            </a:endParaRPr>
+          </a:p>
+        </p:txBody>
+      </p:sp>
+      <p:sp>
+        <p:nvSpPr>
+          <p:cNvPr id="22" name="Role_3">
+            <a:extLst>
+              <a:ext uri="{FF2B5EF4-FFF2-40B4-BE49-F238E27FC236}">
+                <a16:creationId xmlns:a16="http://schemas.microsoft.com/office/drawing/2014/main" id="{338B1B08-CC77-087C-D49C-F66BCF289F15}"/>
+              </a:ext>
+            </a:extLst>
+          </p:cNvPr>
+          <p:cNvSpPr>
+            <a:spLocks noChangeAspect="1"/>
+          </p:cNvSpPr>
+          <p:nvPr/>
+        </p:nvSpPr>
+        <p:spPr bwMode="auto">
+          <a:xfrm>
+            <a:off x="3587764" y="2929308"/>
+            <a:ext cx="8155581" cy="576002"/>
+          </a:xfrm>
+          <a:prstGeom prst="rect">
+            <a:avLst/>
+          </a:prstGeom>
+          <a:ln>
+            <a:noFill/>
+          </a:ln>
+        </p:spPr>
+        <p:style>
+          <a:lnRef idx="2">
+            <a:schemeClr val="accent1"/>
+          </a:lnRef>
+          <a:fillRef idx="1">
+            <a:schemeClr val="lt1"/>
+          </a:fillRef>
+          <a:effectRef idx="0">
+            <a:schemeClr val="accent1"/>
+          </a:effectRef>
+          <a:fontRef idx="minor">
+            <a:schemeClr val="dk1"/>
+          </a:fontRef>
+        </p:style>
+        <p:txBody>
+          <a:bodyPr lIns="91440" tIns="91440" rIns="91440" bIns="91440" rtlCol="0" anchor="t">
+            <a:noAutofit/>
+          </a:bodyPr>
+          <a:lstStyle/>
+          <a:p>
+            <a:pPr fontAlgn="base">
+              <a:defRPr/>
+            </a:pPr>
+            <a:endParaRPr lang="es-AR" sz="900" dirty="0">
+              <a:solidFill>
+                <a:srgbClr val="666666"/>
+              </a:solidFill>
+              <a:latin typeface="Graphik" panose="020B0503030202060203" pitchFamily="34" charset="0"/>
+              <a:cs typeface="Calibri" panose="020F0502020204030204" pitchFamily="34" charset="0"/>
+            </a:endParaRPr>
+          </a:p>
+        </p:txBody>
+      </p:sp>
+      <p:sp>
+        <p:nvSpPr>
+          <p:cNvPr id="23" name="Role_4">
+            <a:extLst>
+              <a:ext uri="{FF2B5EF4-FFF2-40B4-BE49-F238E27FC236}">
+                <a16:creationId xmlns:a16="http://schemas.microsoft.com/office/drawing/2014/main" id="{71CFF229-F5CF-3BCD-DDF1-252E7CCACCF9}"/>
+              </a:ext>
+            </a:extLst>
+          </p:cNvPr>
+          <p:cNvSpPr>
+            <a:spLocks noChangeAspect="1"/>
+          </p:cNvSpPr>
+          <p:nvPr/>
+        </p:nvSpPr>
+        <p:spPr bwMode="auto">
+          <a:xfrm>
+            <a:off x="3587764" y="3559199"/>
+            <a:ext cx="8155581" cy="576002"/>
+          </a:xfrm>
+          <a:prstGeom prst="rect">
+            <a:avLst/>
+          </a:prstGeom>
+          <a:ln>
+            <a:noFill/>
+          </a:ln>
+        </p:spPr>
+        <p:style>
+          <a:lnRef idx="2">
+            <a:schemeClr val="accent1"/>
+          </a:lnRef>
+          <a:fillRef idx="1">
+            <a:schemeClr val="lt1"/>
+          </a:fillRef>
+          <a:effectRef idx="0">
+            <a:schemeClr val="accent1"/>
+          </a:effectRef>
+          <a:fontRef idx="minor">
+            <a:schemeClr val="dk1"/>
+          </a:fontRef>
+        </p:style>
+        <p:txBody>
+          <a:bodyPr lIns="91440" tIns="91440" rIns="91440" bIns="91440" rtlCol="0" anchor="t">
+            <a:noAutofit/>
+          </a:bodyPr>
+          <a:lstStyle/>
+          <a:p>
+            <a:pPr fontAlgn="base">
+              <a:defRPr/>
+            </a:pPr>
+            <a:endParaRPr lang="es-AR" sz="900" dirty="0">
+              <a:solidFill>
+                <a:srgbClr val="666666"/>
+              </a:solidFill>
+              <a:latin typeface="Graphik" panose="020B0503030202060203" pitchFamily="34" charset="0"/>
+              <a:cs typeface="Calibri" panose="020F0502020204030204" pitchFamily="34" charset="0"/>
+            </a:endParaRPr>
+          </a:p>
+        </p:txBody>
+      </p:sp>
+      <p:sp>
+        <p:nvSpPr>
+          <p:cNvPr id="24" name="Role_5">
+            <a:extLst>
+              <a:ext uri="{FF2B5EF4-FFF2-40B4-BE49-F238E27FC236}">
+                <a16:creationId xmlns:a16="http://schemas.microsoft.com/office/drawing/2014/main" id="{ED32BEC5-542E-9A98-5D36-8C5C1AA44BEE}"/>
+              </a:ext>
+            </a:extLst>
+          </p:cNvPr>
+          <p:cNvSpPr>
+            <a:spLocks noChangeAspect="1"/>
+          </p:cNvSpPr>
+          <p:nvPr/>
+        </p:nvSpPr>
+        <p:spPr bwMode="auto">
+          <a:xfrm>
+            <a:off x="3587764" y="4189090"/>
+            <a:ext cx="8155581" cy="576002"/>
+          </a:xfrm>
+          <a:prstGeom prst="rect">
+            <a:avLst/>
+          </a:prstGeom>
+          <a:ln>
+            <a:noFill/>
+          </a:ln>
+        </p:spPr>
+        <p:style>
+          <a:lnRef idx="2">
+            <a:schemeClr val="accent1"/>
+          </a:lnRef>
+          <a:fillRef idx="1">
+            <a:schemeClr val="lt1"/>
+          </a:fillRef>
+          <a:effectRef idx="0">
+            <a:schemeClr val="accent1"/>
+          </a:effectRef>
+          <a:fontRef idx="minor">
+            <a:schemeClr val="dk1"/>
+          </a:fontRef>
+        </p:style>
+        <p:txBody>
+          <a:bodyPr lIns="91440" tIns="91440" rIns="91440" bIns="91440" rtlCol="0" anchor="t">
+            <a:noAutofit/>
+          </a:bodyPr>
+          <a:lstStyle/>
+          <a:p>
+            <a:pPr fontAlgn="base">
+              <a:defRPr/>
+            </a:pPr>
+            <a:endParaRPr lang="es-AR" sz="900" dirty="0">
+              <a:solidFill>
+                <a:srgbClr val="666666"/>
+              </a:solidFill>
+              <a:latin typeface="Graphik" panose="020B0503030202060203" pitchFamily="34" charset="0"/>
+              <a:cs typeface="Calibri" panose="020F0502020204030204" pitchFamily="34" charset="0"/>
+            </a:endParaRPr>
+          </a:p>
+        </p:txBody>
+      </p:sp>
+      <p:sp>
+        <p:nvSpPr>
+          <p:cNvPr id="25" name="Role_6">
+            <a:extLst>
+              <a:ext uri="{FF2B5EF4-FFF2-40B4-BE49-F238E27FC236}">
+                <a16:creationId xmlns:a16="http://schemas.microsoft.com/office/drawing/2014/main" id="{D641828F-96A3-54AF-7F03-AD51F4337059}"/>
+              </a:ext>
+            </a:extLst>
+          </p:cNvPr>
+          <p:cNvSpPr>
+            <a:spLocks noChangeAspect="1"/>
+          </p:cNvSpPr>
+          <p:nvPr/>
+        </p:nvSpPr>
+        <p:spPr bwMode="auto">
+          <a:xfrm>
+            <a:off x="3587764" y="4849495"/>
+            <a:ext cx="8155581" cy="576002"/>
+          </a:xfrm>
+          <a:prstGeom prst="rect">
+            <a:avLst/>
+          </a:prstGeom>
+          <a:ln>
+            <a:noFill/>
+          </a:ln>
+        </p:spPr>
+        <p:style>
+          <a:lnRef idx="2">
+            <a:schemeClr val="accent1"/>
+          </a:lnRef>
+          <a:fillRef idx="1">
+            <a:schemeClr val="lt1"/>
+          </a:fillRef>
+          <a:effectRef idx="0">
+            <a:schemeClr val="accent1"/>
+          </a:effectRef>
+          <a:fontRef idx="minor">
+            <a:schemeClr val="dk1"/>
+          </a:fontRef>
+        </p:style>
+        <p:txBody>
+          <a:bodyPr lIns="91440" tIns="91440" rIns="91440" bIns="91440" rtlCol="0" anchor="t">
+            <a:noAutofit/>
+          </a:bodyPr>
+          <a:lstStyle/>
+          <a:p>
+            <a:pPr fontAlgn="base">
+              <a:defRPr/>
+            </a:pPr>
+            <a:endParaRPr lang="es-AR" sz="900" dirty="0">
+              <a:solidFill>
+                <a:srgbClr val="666666"/>
+              </a:solidFill>
+              <a:latin typeface="Graphik" panose="020B0503030202060203" pitchFamily="34" charset="0"/>
+              <a:cs typeface="Calibri" panose="020F0502020204030204" pitchFamily="34" charset="0"/>
+            </a:endParaRPr>
+          </a:p>
+        </p:txBody>
+      </p:sp>
+      <p:sp>
+        <p:nvSpPr>
+          <p:cNvPr id="26" name="Role_7">
+            <a:extLst>
+              <a:ext uri="{FF2B5EF4-FFF2-40B4-BE49-F238E27FC236}">
+                <a16:creationId xmlns:a16="http://schemas.microsoft.com/office/drawing/2014/main" id="{765E2949-CC4F-D87A-7E1E-810525829290}"/>
+              </a:ext>
+            </a:extLst>
+          </p:cNvPr>
+          <p:cNvSpPr>
+            <a:spLocks noChangeAspect="1"/>
+          </p:cNvSpPr>
+          <p:nvPr/>
+        </p:nvSpPr>
+        <p:spPr bwMode="auto">
+          <a:xfrm>
+            <a:off x="3587764" y="5479386"/>
+            <a:ext cx="8155581" cy="576002"/>
+          </a:xfrm>
+          <a:prstGeom prst="rect">
+            <a:avLst/>
+          </a:prstGeom>
+          <a:ln>
+            <a:noFill/>
+          </a:ln>
+        </p:spPr>
+        <p:style>
+          <a:lnRef idx="2">
+            <a:schemeClr val="accent1"/>
+          </a:lnRef>
+          <a:fillRef idx="1">
+            <a:schemeClr val="lt1"/>
+          </a:fillRef>
+          <a:effectRef idx="0">
+            <a:schemeClr val="accent1"/>
+          </a:effectRef>
+          <a:fontRef idx="minor">
+            <a:schemeClr val="dk1"/>
+          </a:fontRef>
+        </p:style>
+        <p:txBody>
+          <a:bodyPr lIns="91440" tIns="91440" rIns="91440" bIns="91440" rtlCol="0" anchor="t">
+            <a:noAutofit/>
+          </a:bodyPr>
+          <a:lstStyle/>
+          <a:p>
+            <a:pPr fontAlgn="base">
+              <a:defRPr/>
+            </a:pPr>
+            <a:endParaRPr lang="es-AR" sz="900" dirty="0">
+              <a:solidFill>
+                <a:srgbClr val="666666"/>
+              </a:solidFill>
+              <a:latin typeface="Graphik" panose="020B0503030202060203" pitchFamily="34" charset="0"/>
+              <a:cs typeface="Calibri" panose="020F0502020204030204" pitchFamily="34" charset="0"/>
+            </a:endParaRPr>
+          </a:p>
+        </p:txBody>
+      </p:sp>
+      <p:sp>
+        <p:nvSpPr>
+          <p:cNvPr id="27" name="Role_8">
+            <a:extLst>
+              <a:ext uri="{FF2B5EF4-FFF2-40B4-BE49-F238E27FC236}">
+                <a16:creationId xmlns:a16="http://schemas.microsoft.com/office/drawing/2014/main" id="{91147543-93F4-EE64-7E95-BA231CC75680}"/>
+              </a:ext>
+            </a:extLst>
+          </p:cNvPr>
+          <p:cNvSpPr>
+            <a:spLocks noChangeAspect="1"/>
+          </p:cNvSpPr>
+          <p:nvPr/>
+        </p:nvSpPr>
+        <p:spPr bwMode="auto">
+          <a:xfrm>
+            <a:off x="3587764" y="6109277"/>
+            <a:ext cx="8155581" cy="576002"/>
           </a:xfrm>
           <a:prstGeom prst="rect">
             <a:avLst/>
@@ -3744,18 +3988,18 @@
 </file>
 
 <file path=customXml/item1.xml><?xml version="1.0" encoding="utf-8"?>
-<p:properties xmlns:p="http://schemas.microsoft.com/office/2006/metadata/properties" xmlns:xsi="http://www.w3.org/2001/XMLSchema-instance" xmlns:pc="http://schemas.microsoft.com/office/infopath/2007/PartnerControls">
-  <documentManagement/>
-</p:properties>
-</file>
-
-<file path=customXml/item2.xml><?xml version="1.0" encoding="utf-8"?>
 <?mso-contentType ?>
 <FormTemplates xmlns="http://schemas.microsoft.com/sharepoint/v3/contenttype/forms">
   <Display>DocumentLibraryForm</Display>
   <Edit>DocumentLibraryForm</Edit>
   <New>DocumentLibraryForm</New>
 </FormTemplates>
+</file>
+
+<file path=customXml/item2.xml><?xml version="1.0" encoding="utf-8"?>
+<p:properties xmlns:p="http://schemas.microsoft.com/office/2006/metadata/properties" xmlns:xsi="http://www.w3.org/2001/XMLSchema-instance" xmlns:pc="http://schemas.microsoft.com/office/infopath/2007/PartnerControls">
+  <documentManagement/>
+</p:properties>
 </file>
 
 <file path=customXml/item3.xml><?xml version="1.0" encoding="utf-8"?>
@@ -3897,6 +4141,14 @@
 </file>
 
 <file path=customXml/itemProps1.xml><?xml version="1.0" encoding="utf-8"?>
+<ds:datastoreItem xmlns:ds="http://schemas.openxmlformats.org/officeDocument/2006/customXml" ds:itemID="{30F3E009-88A6-4F40-9C86-AA050DF5913C}">
+  <ds:schemaRefs>
+    <ds:schemaRef ds:uri="http://schemas.microsoft.com/sharepoint/v3/contenttype/forms"/>
+  </ds:schemaRefs>
+</ds:datastoreItem>
+</file>
+
+<file path=customXml/itemProps2.xml><?xml version="1.0" encoding="utf-8"?>
 <ds:datastoreItem xmlns:ds="http://schemas.openxmlformats.org/officeDocument/2006/customXml" ds:itemID="{F2D50EAB-2684-422C-B131-B84D670ED6B6}">
   <ds:schemaRefs>
     <ds:schemaRef ds:uri="http://www.w3.org/XML/1998/namespace"/>
@@ -3909,14 +4161,6 @@
     <ds:schemaRef ds:uri="http://schemas.openxmlformats.org/package/2006/metadata/core-properties"/>
     <ds:schemaRef ds:uri="94cbf6cc-ebf7-49eb-9fe4-f3ecb06996f5"/>
     <ds:schemaRef ds:uri="http://purl.org/dc/elements/1.1/"/>
-  </ds:schemaRefs>
-</ds:datastoreItem>
-</file>
-
-<file path=customXml/itemProps2.xml><?xml version="1.0" encoding="utf-8"?>
-<ds:datastoreItem xmlns:ds="http://schemas.openxmlformats.org/officeDocument/2006/customXml" ds:itemID="{30F3E009-88A6-4F40-9C86-AA050DF5913C}">
-  <ds:schemaRefs>
-    <ds:schemaRef ds:uri="http://schemas.microsoft.com/sharepoint/v3/contenttype/forms"/>
   </ds:schemaRefs>
 </ds:datastoreItem>
 </file>

</xml_diff>